<commit_message>
Refine combined slide leader layout
Co-authored-by: stepross <stepross@users.noreply.github.com>
</commit_message>
<xml_diff>
--- a/COverage_combined.pptx
+++ b/COverage_combined.pptx
@@ -21436,7 +21436,7 @@
                 <a:defRPr/>
               </a:pPr>
               <a:r>
-                <a:rPr kumimoji="0" lang="en-US" sz="2000" b="0" i="0" u="none" strike="noStrike" kern="1200" cap="none" spc="0" normalizeH="0" baseline="0" noProof="0">
+                <a:rPr kumimoji="0" lang="en-US" sz="1400" b="0" i="0" u="none" strike="noStrike" kern="1200" cap="none" spc="0" normalizeH="0" baseline="0" noProof="0">
                   <a:ln>
                     <a:noFill/>
                   </a:ln>
@@ -21474,7 +21474,7 @@
                 <a:defRPr/>
               </a:pPr>
               <a:r>
-                <a:rPr kumimoji="0" lang="en-US" sz="1400" b="0" i="0" u="none" strike="noStrike" kern="1200" cap="none" spc="0" normalizeH="0" baseline="0" noProof="0">
+                <a:rPr kumimoji="0" lang="en-US" sz="950" b="0" i="0" u="none" strike="noStrike" kern="1200" cap="none" spc="0" normalizeH="0" baseline="0" noProof="0">
                   <a:ln>
                     <a:noFill/>
                   </a:ln>
@@ -22894,7 +22894,7 @@
                 <a:defRPr/>
               </a:pPr>
               <a:r>
-                <a:rPr kumimoji="0" lang="en-US" sz="2000" b="0" i="0" u="none" strike="noStrike" kern="1200" cap="none" spc="0" normalizeH="0" baseline="0" noProof="0">
+                <a:rPr kumimoji="0" lang="en-US" sz="1400" b="0" i="0" u="none" strike="noStrike" kern="1200" cap="none" spc="0" normalizeH="0" baseline="0" noProof="0">
                   <a:ln>
                     <a:noFill/>
                   </a:ln>
@@ -22932,7 +22932,7 @@
                 <a:defRPr/>
               </a:pPr>
               <a:r>
-                <a:rPr kumimoji="0" lang="en-US" sz="1400" b="0" i="0" u="none" strike="noStrike" kern="1200" cap="none" spc="0" normalizeH="0" baseline="0" noProof="0">
+                <a:rPr kumimoji="0" lang="en-US" sz="950" b="0" i="0" u="none" strike="noStrike" kern="1200" cap="none" spc="0" normalizeH="0" baseline="0" noProof="0">
                   <a:ln>
                     <a:noFill/>
                   </a:ln>
@@ -24525,7 +24525,7 @@
                 <a:defRPr/>
               </a:pPr>
               <a:r>
-                <a:rPr kumimoji="0" lang="en-US" sz="2000" b="0" i="0" u="none" strike="noStrike" kern="1200" cap="none" spc="0" normalizeH="0" baseline="0" noProof="0">
+                <a:rPr kumimoji="0" lang="en-US" sz="1400" b="0" i="0" u="none" strike="noStrike" kern="1200" cap="none" spc="0" normalizeH="0" baseline="0" noProof="0">
                   <a:ln>
                     <a:noFill/>
                   </a:ln>
@@ -24563,7 +24563,7 @@
                 <a:defRPr/>
               </a:pPr>
               <a:r>
-                <a:rPr kumimoji="0" lang="en-US" sz="1400" b="0" i="0" u="none" strike="noStrike" kern="1200" cap="none" spc="0" normalizeH="0" baseline="0" noProof="0">
+                <a:rPr kumimoji="0" lang="en-US" sz="950" b="0" i="0" u="none" strike="noStrike" kern="1200" cap="none" spc="0" normalizeH="0" baseline="0" noProof="0">
                   <a:ln>
                     <a:noFill/>
                   </a:ln>

</xml_diff>